<commit_message>
feat(website): harness wording. (#1211)
* feat(website): harness wording

* more things

* fix it
</commit_message>
<xml_diff>
--- a/website/public/seminars/qwen-korea-meetup-20260326.pptx
+++ b/website/public/seminars/qwen-korea-meetup-20260326.pptx
@@ -8,28 +8,28 @@
     <p:notesMasterId r:id="rId73"/>
   </p:notesMasterIdLst>
   <p:sldIdLst>
-    <p:sldId id="504" r:id="rId2"/>
-    <p:sldId id="505" r:id="rId3"/>
-    <p:sldId id="506" r:id="rId4"/>
+    <p:sldId id="541" r:id="rId2"/>
+    <p:sldId id="514" r:id="rId3"/>
+    <p:sldId id="542" r:id="rId4"/>
     <p:sldId id="407" r:id="rId5"/>
-    <p:sldId id="408" r:id="rId6"/>
+    <p:sldId id="543" r:id="rId6"/>
     <p:sldId id="483" r:id="rId7"/>
     <p:sldId id="484" r:id="rId8"/>
     <p:sldId id="485" r:id="rId9"/>
-    <p:sldId id="486" r:id="rId10"/>
+    <p:sldId id="544" r:id="rId10"/>
     <p:sldId id="413" r:id="rId11"/>
     <p:sldId id="414" r:id="rId12"/>
-    <p:sldId id="415" r:id="rId13"/>
+    <p:sldId id="545" r:id="rId13"/>
     <p:sldId id="416" r:id="rId14"/>
-    <p:sldId id="417" r:id="rId15"/>
+    <p:sldId id="546" r:id="rId15"/>
     <p:sldId id="418" r:id="rId16"/>
     <p:sldId id="419" r:id="rId17"/>
     <p:sldId id="493" r:id="rId18"/>
     <p:sldId id="481" r:id="rId19"/>
-    <p:sldId id="421" r:id="rId20"/>
-    <p:sldId id="422" r:id="rId21"/>
-    <p:sldId id="423" r:id="rId22"/>
-    <p:sldId id="424" r:id="rId23"/>
+    <p:sldId id="547" r:id="rId20"/>
+    <p:sldId id="548" r:id="rId21"/>
+    <p:sldId id="549" r:id="rId22"/>
+    <p:sldId id="550" r:id="rId23"/>
     <p:sldId id="425" r:id="rId24"/>
     <p:sldId id="426" r:id="rId25"/>
     <p:sldId id="427" r:id="rId26"/>
@@ -49,36 +49,36 @@
     <p:sldId id="469" r:id="rId40"/>
     <p:sldId id="470" r:id="rId41"/>
     <p:sldId id="507" r:id="rId42"/>
-    <p:sldId id="439" r:id="rId43"/>
-    <p:sldId id="440" r:id="rId44"/>
+    <p:sldId id="520" r:id="rId43"/>
+    <p:sldId id="551" r:id="rId44"/>
     <p:sldId id="471" r:id="rId45"/>
     <p:sldId id="442" r:id="rId46"/>
     <p:sldId id="443" r:id="rId47"/>
     <p:sldId id="444" r:id="rId48"/>
-    <p:sldId id="445" r:id="rId49"/>
+    <p:sldId id="522" r:id="rId49"/>
     <p:sldId id="446" r:id="rId50"/>
-    <p:sldId id="447" r:id="rId51"/>
-    <p:sldId id="448" r:id="rId52"/>
-    <p:sldId id="449" r:id="rId53"/>
-    <p:sldId id="474" r:id="rId54"/>
+    <p:sldId id="536" r:id="rId51"/>
+    <p:sldId id="552" r:id="rId52"/>
+    <p:sldId id="553" r:id="rId53"/>
+    <p:sldId id="532" r:id="rId54"/>
     <p:sldId id="475" r:id="rId55"/>
     <p:sldId id="496" r:id="rId56"/>
     <p:sldId id="476" r:id="rId57"/>
     <p:sldId id="497" r:id="rId58"/>
     <p:sldId id="508" r:id="rId59"/>
-    <p:sldId id="453" r:id="rId60"/>
-    <p:sldId id="454" r:id="rId61"/>
+    <p:sldId id="534" r:id="rId60"/>
+    <p:sldId id="554" r:id="rId61"/>
     <p:sldId id="472" r:id="rId62"/>
     <p:sldId id="456" r:id="rId63"/>
-    <p:sldId id="457" r:id="rId64"/>
-    <p:sldId id="458" r:id="rId65"/>
-    <p:sldId id="473" r:id="rId66"/>
-    <p:sldId id="460" r:id="rId67"/>
+    <p:sldId id="555" r:id="rId64"/>
+    <p:sldId id="535" r:id="rId65"/>
+    <p:sldId id="556" r:id="rId66"/>
+    <p:sldId id="528" r:id="rId67"/>
     <p:sldId id="461" r:id="rId68"/>
-    <p:sldId id="480" r:id="rId69"/>
+    <p:sldId id="557" r:id="rId69"/>
     <p:sldId id="463" r:id="rId70"/>
-    <p:sldId id="464" r:id="rId71"/>
-    <p:sldId id="465" r:id="rId72"/>
+    <p:sldId id="558" r:id="rId71"/>
+    <p:sldId id="531" r:id="rId72"/>
   </p:sldIdLst>
   <p:sldSz cx="12192000" cy="6858000"/>
   <p:notesSz cx="6858000" cy="9144000"/>
@@ -267,7 +267,7 @@
           <a:p>
             <a:fld id="{2E60F9CA-1A93-4D79-84D7-7CA1A1B56831}" type="datetimeFigureOut">
               <a:rPr lang="ko-KR" altLang="en-US" smtClean="0"/>
-              <a:t>2026-03-19</a:t>
+              <a:t>2026-03-20</a:t>
             </a:fld>
             <a:endParaRPr lang="ko-KR" altLang="en-US"/>
           </a:p>
@@ -580,7 +580,7 @@
           <a:p>
             <a:r>
               <a:rPr lang="ko-KR" dirty="0"/>
-              <a:t>안녕하세요. 오늘 발표 제목은 'Function Calling All-In'입니다. AutoBe가 어떻게 Qwen 모델 4종 모두에서 100% 컴파일 성공률을 달성했는지, 그 이면의 인프라와 방법론을 소개합니다.</a:t>
+              <a:t>안녕하세요. 오늘 발표 제목은 'Function Calling Harness'입니다. AutoBe가 어떻게 Qwen 모델 4종 모두에서 100% 컴파일 성공률을 달성했는지, 그 이면의 하네스(harness) 아키텍처를 소개합니다.</a:t>
             </a:r>
           </a:p>
         </p:txBody>
@@ -757,7 +757,7 @@
           <a:p>
             <a:r>
               <a:rPr lang="ko-KR" dirty="0"/>
-              <a:t>이렇게 복잡한 구조에서 첫 시도 성공률이 낮은 건 당연합니다. 진짜 질문은 어떻게 100%로 만드느냐입니다. 답은 검증 피드백 루프입니다.</a:t>
+              <a:t>이렇게 복잡한 구조에서 첫 시도 성공률이 낮은 건 당연합니다. 진짜 질문은 어떻게 100%로 만드느냐입니다. 답은 하네스입니다. 타입 스키마가 출력을 제약하고, 컴파일러가 검증하고, 구조화된 피드백이 에러를 짚어줍니다. 이 결정론적 루프가 확률적 모델을 감싸는 하네스입니다.</a:t>
             </a:r>
           </a:p>
         </p:txBody>
@@ -875,7 +875,7 @@
           <a:p>
             <a:r>
               <a:rPr lang="ko-KR" dirty="0"/>
-              <a:t>이 피드백을 받으면 LLM은 처음부터 다시 생성할 필요가 없습니다. 표시된 필드만 정확히 수정하면 됩니다. 컴파일러 검증, 정밀 진단, LLM 수정, 재검증. 이 루프가 성공할 때까지 반복됩니다.</a:t>
+              <a:t>이 피드백을 받으면 LLM은 처음부터 다시 생성할 필요가 없습니다. 표시된 필드만 정확히 수정하면 됩니다. 컴파일러 검증, 정밀 진단, LLM 수정, 재검증. 이 루프가 바로 하네스입니다. 한 번이든 열 번이든, 최종 결과는 100%입니다.</a:t>
             </a:r>
           </a:p>
         </p:txBody>
@@ -1198,7 +1198,7 @@
           <a:p>
             <a:r>
               <a:rPr lang="ko-KR" dirty="0"/>
-              <a:t>AutoBe가 테스트하는 Qwen 모델 4종입니다. 397B부터 35B까지. 활성 파라미터 3B짜리 소형 모델조차 완전한 쇼핑몰 백엔드를 생성합니다. 전부 100%.</a:t>
+              <a:t>AutoBe가 테스트하는 Qwen 모델 4종입니다. 397B부터 35B까지. 활성 파라미터 3B짜리 소형 모델조차 완전한 쇼핑몰 백엔드를 생성합니다. 전부 100%. 같은 하네스, 같은 스키마, 같은 결과입니다.</a:t>
             </a:r>
           </a:p>
         </p:txBody>
@@ -1316,7 +1316,7 @@
           <a:p>
             <a:r>
               <a:rPr lang="ko-KR" dirty="0"/>
-              <a:t>일화 하나. 시스템 프롬프트가 빠진 빌드를 배포한 적이 있습니다. 아무도 눈치채지 못했습니다. 타입이 최고의 프롬프트였고, 검증 피드백이 최고의 오케스트레이션이었습니다.</a:t>
+              <a:t>일화 하나. 시스템 프롬프트가 빠진 빌드를 배포한 적이 있습니다. 아무도 눈치채지 못했습니다. 타입이 최고의 프롬프트였고, 하네스가 최고의 오케스트레이션이었습니다.</a:t>
             </a:r>
           </a:p>
         </p:txBody>
@@ -1375,7 +1375,7 @@
           <a:p>
             <a:r>
               <a:rPr lang="ko-KR" dirty="0"/>
-              <a:t>챕터 2. Typia — 이 모든 것의 인프라입니다.</a:t>
+              <a:t>챕터 2. Typia — 하네스의 내부입니다. Typia가 하네스의 엔진입니다.</a:t>
             </a:r>
           </a:p>
         </p:txBody>
@@ -1434,7 +1434,7 @@
           <a:p>
             <a:r>
               <a:rPr lang="ko-KR" dirty="0"/>
-              <a:t>1장에서 계속 등장했던 것들 — 스키마 변환, 깨진 JSON 복구, 타입 교정, 정밀 에러 피드백. Typia가 단일 라이브러리로 전부 처리합니다.</a:t>
+              <a:t>1장에서 계속 등장했던 것들 — 스키마 변환, 깨진 JSON 복구, 타입 교정, 정밀 에러 피드백. Typia가 단일 라이브러리로 전부 처리합니다. 하네스의 엔진입니다.</a:t>
             </a:r>
           </a:p>
         </p:txBody>
@@ -1906,7 +1906,7 @@
           <a:p>
             <a:r>
               <a:rPr lang="ko-KR" dirty="0"/>
-              <a:t>function calling이 왜 정밀한 도메인에 적합한 방법론인지, 그리고 왜 Qwen인지에 대해서도 다룹니다. 핵심 메시지는 하나입니다 — LLM이 정확할 필요는 없다. 교정 가능하기만 하면 된다.</a:t>
+              <a:t>function calling이 왜 정밀한 도메인에 적합한 방법론인지, 그리고 왜 Qwen인지에 대해서도 다룹니다. 핵심 메시지는 하나입니다 — LLM이 정확할 필요는 없다. 하네스 안에만 있으면 된다.</a:t>
             </a:r>
           </a:p>
         </p:txBody>
@@ -2906,7 +2906,7 @@
           <a:p>
             <a:r>
               <a:rPr lang="ko-KR" dirty="0"/>
-              <a:t>챕터 3. Function Calling의 논거. how를 봤으니 이제 why입니다.</a:t>
+              <a:t>챕터 3. 왜 하네스인가, 프롬프트가 아니라. how를 봤으니 이제 why입니다. 프롬프트 엔지니어링은 모델 내부를 손본다면, 하네스는 외부를 견고하게 만듭니다.</a:t>
             </a:r>
           </a:p>
         </p:txBody>
@@ -3319,7 +3319,7 @@
           <a:p>
             <a:r>
               <a:rPr lang="ko-KR" dirty="0"/>
-              <a:t>그런데 AutoBe의 최종 컴파일 성공률은 100%입니다. Qwen 모델 4종 전부에서요. 6.75%에서 100%로. 오늘 그 여정을 이야기합니다.</a:t>
+              <a:t>그런데 AutoBe의 최종 컴파일 성공률은 100%입니다. Qwen 모델 4종 전부에서요. 6.75%에서 100%로. 그 차이를 만든 건 더 나은 모델도, 더 똑똑한 프롬프트도 아닙니다. 하네스(harness)입니다.</a:t>
             </a:r>
           </a:p>
         </p:txBody>
@@ -3437,7 +3437,7 @@
           <a:p>
             <a:r>
               <a:rPr lang="ko-KR" dirty="0"/>
-              <a:t>공식입니다. 타입 스키마 + 결정적 검증기 + 구조화된 에러 피드백 = 신뢰할 수 있는 LLM 출력. 이 공식이 AutoBe의 전부입니다.</a:t>
+              <a:t>공식입니다. 타입 스키마 + 결정적 검증기 + 구조화된 피드백 = 하네스. 프롬프트 엔지니어링은 확률적인 부분을 안정시키려 합니다. 하네스는 결정적인 부분을 견고하게 만듭니다. 정밀도가 필요한 도메인에서는 후자가 이깁니다.</a:t>
             </a:r>
           </a:p>
         </p:txBody>
@@ -3496,7 +3496,7 @@
           <a:p>
             <a:r>
               <a:rPr lang="ko-KR" dirty="0"/>
-              <a:t>LLM은 정확할 필요가 없습니다. 교정 가능하기만 하면 됩니다. 이것이 패러다임 전환입니다.</a:t>
+              <a:t>LLM은 정확할 필요가 없습니다. 하네스 안에만 있으면 됩니다. 더 나은 프롬프트가 아니라, 더 나은 하네스를 만드세요.</a:t>
             </a:r>
           </a:p>
         </p:txBody>
@@ -4050,7 +4050,7 @@
           <a:p>
             <a:r>
               <a:rPr lang="ko-KR" dirty="0"/>
-              <a:t>챕터 4. Why Qwen. 왜 Qwen 모델을 선택했는가.</a:t>
+              <a:t>챕터 4. Qwen — 하네스의 스트레스 테스트. 하네스는 스트레스 테스트만큼만 견고합니다.</a:t>
             </a:r>
           </a:p>
         </p:txBody>
@@ -4227,7 +4227,7 @@
           <a:p>
             <a:r>
               <a:rPr lang="ko-KR" dirty="0"/>
-              <a:t>소형 모델은 최고의 QA 엔지니어입니다. 약해서 더 많은 반례를 만들어내고, 그 반례가 시스템을 강화합니다.</a:t>
+              <a:t>소형 모델은 최고의 QA 엔지니어입니다. 약해서 더 많은 반례를 만들어내고, 그 반례가 하네스를 강화합니다.</a:t>
             </a:r>
           </a:p>
         </p:txBody>
@@ -4345,7 +4345,7 @@
           <a:p>
             <a:r>
               <a:rPr lang="ko-KR" dirty="0"/>
-              <a:t>오픈소스 Typia와 오픈웨이트 Qwen의 조합. 두 프로젝트 모두 소스가 공개되어 있어서 누구나 재현하고 확장할 수 있습니다.</a:t>
+              <a:t>오픈소스 Typia와 오픈웨이트 Qwen의 조합. 두 프로젝트 모두 소스가 공개되어 있어서 누구나 재현하고 확장할 수 있습니다. AutoBe는 Qwen으로 하네스를 단련하고, 단련된 하네스가 Qwen의 프로덕션 수준 활용 가능성을 증명합니다.</a:t>
             </a:r>
           </a:p>
         </p:txBody>
@@ -4522,7 +4522,7 @@
           <a:p>
             <a:r>
               <a:rPr lang="ko-KR" dirty="0"/>
-              <a:t>6.75%에서 100%까지의 여정을 돌아봅니다. 복잡한 타입, 깨진 JSON, 잘못된 값. 하나씩 해결해서 여기까지 왔습니다.</a:t>
+              <a:t>6.75%에서 100%까지의 여정을 돌아봅니다. 복잡한 타입, 깨진 JSON, 잘못된 값. 하나씩 해결해서 여기까지 왔습니다. 하네스 세 가지 — 타입 스키마가 출력을 제약하고, 컴파일러가 검증하고, 구조화된 피드백이 교정합니다. 이 패턴은 코드 생성에만 한정되지 않습니다.</a:t>
             </a:r>
           </a:p>
         </p:txBody>
@@ -4699,7 +4699,7 @@
           <a:p>
             <a:r>
               <a:rPr lang="ko-KR" dirty="0"/>
-              <a:t>핵심 메시지. LLM은 정확할 필요가 없습니다. 교정 가능하면 됩니다. 그리고 그 교정의 도구는 이미 우리 손에 있습니다. 타입 시스템입니다.</a:t>
+              <a:t>핵심 메시지. LLM은 정확할 필요가 없습니다. 하네스 안에 있으면 됩니다. 더 나은 프롬프트를 만들지 마세요. 더 나은 하네스를 만드세요. LLM은 정확할 필요가 없습니다. 하네스 안에만 있으면 됩니다.</a:t>
             </a:r>
           </a:p>
         </p:txBody>
@@ -4876,7 +4876,7 @@
           <a:p>
             <a:r>
               <a:rPr lang="ko-KR" dirty="0"/>
-              <a:t>이것이 All-In Function Calling 전략입니다. 5단계 전부에서 같은 패턴이 반복됩니다. 각 타입은 GitHub에서 직접 확인하실 수 있습니다. 링크가 걸려 있습니다.</a:t>
+              <a:t>이것이 AutoBe의 function calling harness입니다. 5단계 전부에서 같은 패턴이 반복됩니다. 각 타입은 GitHub에서 직접 확인하실 수 있습니다. 링크가 걸려 있습니다.</a:t>
             </a:r>
           </a:p>
         </p:txBody>
@@ -5092,7 +5092,7 @@
           <a:p>
             <a:fld id="{ADAB3498-A523-4A42-BB38-782B1991896F}" type="datetimeFigureOut">
               <a:rPr lang="ko-KR" altLang="en-US" smtClean="0"/>
-              <a:t>2026-03-19</a:t>
+              <a:t>2026-03-20</a:t>
             </a:fld>
             <a:endParaRPr lang="ko-KR" altLang="en-US"/>
           </a:p>
@@ -5313,7 +5313,7 @@
           <a:p>
             <a:fld id="{ADAB3498-A523-4A42-BB38-782B1991896F}" type="datetimeFigureOut">
               <a:rPr lang="ko-KR" altLang="en-US" smtClean="0"/>
-              <a:t>2026-03-19</a:t>
+              <a:t>2026-03-20</a:t>
             </a:fld>
             <a:endParaRPr lang="ko-KR" altLang="en-US"/>
           </a:p>
@@ -5493,7 +5493,7 @@
           <a:p>
             <a:fld id="{ADAB3498-A523-4A42-BB38-782B1991896F}" type="datetimeFigureOut">
               <a:rPr lang="ko-KR" altLang="en-US" smtClean="0"/>
-              <a:t>2026-03-19</a:t>
+              <a:t>2026-03-20</a:t>
             </a:fld>
             <a:endParaRPr lang="ko-KR" altLang="en-US"/>
           </a:p>
@@ -5663,7 +5663,7 @@
           <a:p>
             <a:fld id="{ADAB3498-A523-4A42-BB38-782B1991896F}" type="datetimeFigureOut">
               <a:rPr lang="ko-KR" altLang="en-US" smtClean="0"/>
-              <a:t>2026-03-19</a:t>
+              <a:t>2026-03-20</a:t>
             </a:fld>
             <a:endParaRPr lang="ko-KR" altLang="en-US"/>
           </a:p>
@@ -5914,7 +5914,7 @@
           <a:p>
             <a:fld id="{ADAB3498-A523-4A42-BB38-782B1991896F}" type="datetimeFigureOut">
               <a:rPr lang="ko-KR" altLang="en-US" smtClean="0"/>
-              <a:t>2026-03-19</a:t>
+              <a:t>2026-03-20</a:t>
             </a:fld>
             <a:endParaRPr lang="ko-KR" altLang="en-US"/>
           </a:p>
@@ -6237,7 +6237,7 @@
           <a:p>
             <a:fld id="{ADAB3498-A523-4A42-BB38-782B1991896F}" type="datetimeFigureOut">
               <a:rPr lang="ko-KR" altLang="en-US" smtClean="0"/>
-              <a:t>2026-03-19</a:t>
+              <a:t>2026-03-20</a:t>
             </a:fld>
             <a:endParaRPr lang="ko-KR" altLang="en-US"/>
           </a:p>
@@ -6661,7 +6661,7 @@
           <a:p>
             <a:fld id="{ADAB3498-A523-4A42-BB38-782B1991896F}" type="datetimeFigureOut">
               <a:rPr lang="ko-KR" altLang="en-US" smtClean="0"/>
-              <a:t>2026-03-19</a:t>
+              <a:t>2026-03-20</a:t>
             </a:fld>
             <a:endParaRPr lang="ko-KR" altLang="en-US"/>
           </a:p>
@@ -6779,7 +6779,7 @@
           <a:p>
             <a:fld id="{ADAB3498-A523-4A42-BB38-782B1991896F}" type="datetimeFigureOut">
               <a:rPr lang="ko-KR" altLang="en-US" smtClean="0"/>
-              <a:t>2026-03-19</a:t>
+              <a:t>2026-03-20</a:t>
             </a:fld>
             <a:endParaRPr lang="ko-KR" altLang="en-US"/>
           </a:p>
@@ -6874,7 +6874,7 @@
           <a:p>
             <a:fld id="{ADAB3498-A523-4A42-BB38-782B1991896F}" type="datetimeFigureOut">
               <a:rPr lang="ko-KR" altLang="en-US" smtClean="0"/>
-              <a:t>2026-03-19</a:t>
+              <a:t>2026-03-20</a:t>
             </a:fld>
             <a:endParaRPr lang="ko-KR" altLang="en-US"/>
           </a:p>
@@ -7164,7 +7164,7 @@
           <a:p>
             <a:fld id="{ADAB3498-A523-4A42-BB38-782B1991896F}" type="datetimeFigureOut">
               <a:rPr lang="ko-KR" altLang="en-US" smtClean="0"/>
-              <a:t>2026-03-19</a:t>
+              <a:t>2026-03-20</a:t>
             </a:fld>
             <a:endParaRPr lang="ko-KR" altLang="en-US"/>
           </a:p>
@@ -7436,7 +7436,7 @@
           <a:p>
             <a:fld id="{ADAB3498-A523-4A42-BB38-782B1991896F}" type="datetimeFigureOut">
               <a:rPr lang="ko-KR" altLang="en-US" smtClean="0"/>
-              <a:t>2026-03-19</a:t>
+              <a:t>2026-03-20</a:t>
             </a:fld>
             <a:endParaRPr lang="ko-KR" altLang="en-US"/>
           </a:p>
@@ -7707,7 +7707,7 @@
           <a:p>
             <a:fld id="{ADAB3498-A523-4A42-BB38-782B1991896F}" type="datetimeFigureOut">
               <a:rPr lang="ko-KR" altLang="en-US" smtClean="0"/>
-              <a:t>2026-03-19</a:t>
+              <a:t>2026-03-20</a:t>
             </a:fld>
             <a:endParaRPr lang="ko-KR" altLang="en-US"/>
           </a:p>
@@ -8286,7 +8286,7 @@
                 <a:latin typeface="Segoe UI Semibold"/>
                 <a:cs typeface="Segoe UI Semibold"/>
               </a:rPr>
-              <a:t>Function Calling All-In</a:t>
+              <a:t>Function Calling Harness</a:t>
             </a:r>
             <a:endParaRPr lang="ko-KR" altLang="en-US" sz="4200" b="1">
               <a:solidFill>
@@ -8568,7 +8568,7 @@
     </p:spTree>
     <p:extLst>
       <p:ext uri="{BB962C8B-B14F-4D97-AF65-F5344CB8AC3E}">
-        <p14:creationId xmlns:p14="http://schemas.microsoft.com/office/powerpoint/2010/main" val="1998937396"/>
+        <p14:creationId xmlns:p14="http://schemas.microsoft.com/office/powerpoint/2010/main" val="3840939314"/>
       </p:ext>
     </p:extLst>
   </p:cSld>
@@ -10256,7 +10256,7 @@
                 <a:latin typeface="Segoe UI Semibold"/>
                 <a:cs typeface="Segoe UI Semibold"/>
               </a:rPr>
-              <a:t>How 6.75% Becomes 100%</a:t>
+              <a:t>The Harness: How 6.75% Becomes 100%</a:t>
             </a:r>
             <a:endParaRPr lang="ko-KR" altLang="en-US" sz="3200" b="1">
               <a:solidFill>
@@ -10807,7 +10807,7 @@
     </p:spTree>
     <p:extLst>
       <p:ext uri="{BB962C8B-B14F-4D97-AF65-F5344CB8AC3E}">
-        <p14:creationId xmlns:p14="http://schemas.microsoft.com/office/powerpoint/2010/main" val="1802360433"/>
+        <p14:creationId xmlns:p14="http://schemas.microsoft.com/office/powerpoint/2010/main" val="313432963"/>
       </p:ext>
     </p:extLst>
   </p:cSld>
@@ -12229,7 +12229,7 @@
     </p:spTree>
     <p:extLst>
       <p:ext uri="{BB962C8B-B14F-4D97-AF65-F5344CB8AC3E}">
-        <p14:creationId xmlns:p14="http://schemas.microsoft.com/office/powerpoint/2010/main" val="3156232844"/>
+        <p14:creationId xmlns:p14="http://schemas.microsoft.com/office/powerpoint/2010/main" val="3222485243"/>
       </p:ext>
     </p:extLst>
   </p:cSld>
@@ -14478,13 +14478,7 @@
           <p:cNvGraphicFramePr>
             <a:graphicFrameLocks noGrp="1"/>
           </p:cNvGraphicFramePr>
-          <p:nvPr>
-            <p:extLst>
-              <p:ext uri="{D42A27DB-BD31-4B8C-83A1-F6EECF244321}">
-                <p14:modId xmlns:p14="http://schemas.microsoft.com/office/powerpoint/2010/main" val="629231260"/>
-              </p:ext>
-            </p:extLst>
-          </p:nvPr>
+          <p:nvPr/>
         </p:nvGraphicFramePr>
         <p:xfrm>
           <a:off x="1270000" y="1524000"/>
@@ -15129,7 +15123,8 @@
                 </a:solidFill>
               </a:rPr>
               <a:t>From 397B down to 35B — even 3B active params
-generates a complete shopping mall backend</a:t>
+generates a complete shopping mall backend.
+Same harness, same schemas, same result.</a:t>
             </a:r>
             <a:endParaRPr lang="ko-KR" altLang="en-US" sz="2000">
               <a:solidFill>
@@ -15142,7 +15137,7 @@
     </p:spTree>
     <p:extLst>
       <p:ext uri="{BB962C8B-B14F-4D97-AF65-F5344CB8AC3E}">
-        <p14:creationId xmlns:p14="http://schemas.microsoft.com/office/powerpoint/2010/main" val="2707986356"/>
+        <p14:creationId xmlns:p14="http://schemas.microsoft.com/office/powerpoint/2010/main" val="196620415"/>
       </p:ext>
     </p:extLst>
   </p:cSld>
@@ -15305,7 +15300,7 @@
                 </a:solidFill>
                 <a:latin typeface="Segoe UI Semibold"/>
               </a:rPr>
-              <a:t>AutoBe</a:t>
+              <a:t>AutoBe — The Harness in Action</a:t>
             </a:r>
           </a:p>
         </p:txBody>
@@ -15336,7 +15331,7 @@
                   <a:srgbClr val="D0D0D0"/>
                 </a:solidFill>
               </a:rPr>
-              <a:t>▸  A backend AI agent built entirely on function calling</a:t>
+              <a:t>▸  The LLM never writes code — it fills typed structures;</a:t>
             </a:r>
           </a:p>
           <a:p>
@@ -15347,7 +15342,7 @@
                   <a:srgbClr val="D0D0D0"/>
                 </a:solidFill>
               </a:rPr>
-              <a:t>▸  The LLM never writes code — it fills typed structures,</a:t>
+              <a:t>    the compiler converts them to code</a:t>
             </a:r>
           </a:p>
           <a:p>
@@ -15358,7 +15353,7 @@
                   <a:srgbClr val="D0D0D0"/>
                 </a:solidFill>
               </a:rPr>
-              <a:t>    and the compiler converts them to code</a:t>
+              <a:t>▸  Type schema → function calling → compiler → feedback → retry</a:t>
             </a:r>
           </a:p>
           <a:p>
@@ -15369,7 +15364,7 @@
                   <a:srgbClr val="FFE66D"/>
                 </a:solidFill>
               </a:rPr>
-              <a:t>▸  100% compilation success across all 4 Qwen models</a:t>
+              <a:t>▸  100% compilation across all 4 Qwen models, incl. no system prompts</a:t>
             </a:r>
           </a:p>
         </p:txBody>
@@ -15438,7 +15433,7 @@
                 </a:solidFill>
                 <a:latin typeface="Segoe UI Semibold"/>
               </a:rPr>
-              <a:t>Typia</a:t>
+              <a:t>Typia — Inside the Harness</a:t>
             </a:r>
           </a:p>
         </p:txBody>
@@ -15469,7 +15464,7 @@
                   <a:srgbClr val="D0D0D0"/>
                 </a:solidFill>
               </a:rPr>
-              <a:t>▸  Infrastructure that automates the entire function calling lifecycle</a:t>
+              <a:t>▸  Infrastructure that automates the entire FC lifecycle</a:t>
             </a:r>
           </a:p>
           <a:p>
@@ -15502,18 +15497,7 @@
                   <a:srgbClr val="FFE66D"/>
                 </a:solidFill>
               </a:rPr>
-              <a:t>▸  qwen3-coder-next: 6.75% → 100%</a:t>
-            </a:r>
-          </a:p>
-          <a:p>
-            <a:pPr algn="l"/>
-            <a:r>
-              <a:rPr lang="en-US" sz="1800" b="1">
-                <a:solidFill>
-                  <a:srgbClr val="FFE66D"/>
-                </a:solidFill>
-              </a:rPr>
-              <a:t>▸  qwen3.5 series: 0% → 100%</a:t>
+              <a:t>▸  One type drives everything: the schema, the validator, the prompt</a:t>
             </a:r>
           </a:p>
         </p:txBody>
@@ -15521,7 +15505,7 @@
     </p:spTree>
     <p:extLst>
       <p:ext uri="{BB962C8B-B14F-4D97-AF65-F5344CB8AC3E}">
-        <p14:creationId xmlns:p14="http://schemas.microsoft.com/office/powerpoint/2010/main" val="1557886192"/>
+        <p14:creationId xmlns:p14="http://schemas.microsoft.com/office/powerpoint/2010/main" val="2988631370"/>
       </p:ext>
     </p:extLst>
   </p:cSld>
@@ -15595,7 +15579,7 @@
                 <a:latin typeface="Segoe UI Semibold"/>
                 <a:cs typeface="Segoe UI Semibold"/>
               </a:rPr>
-              <a:t>It Runs Without System Prompts</a:t>
+              <a:t>The Harness Runs Without Prompts</a:t>
             </a:r>
             <a:endParaRPr lang="ko-KR" altLang="en-US" sz="3600" b="1">
               <a:solidFill>
@@ -15714,8 +15698,8 @@
                   <a:srgbClr val="FFE66D"/>
                 </a:solidFill>
               </a:rPr>
-              <a:t>The types were the best prompt,
-and validation feedback was the best orchestration.</a:t>
+              <a:t>The types were the best prompt.
+The harness was the best orchestration.</a:t>
             </a:r>
             <a:endParaRPr lang="ko-KR" altLang="en-US" sz="2400" b="1">
               <a:solidFill>
@@ -15728,7 +15712,7 @@
     </p:spTree>
     <p:extLst>
       <p:ext uri="{BB962C8B-B14F-4D97-AF65-F5344CB8AC3E}">
-        <p14:creationId xmlns:p14="http://schemas.microsoft.com/office/powerpoint/2010/main" val="673273091"/>
+        <p14:creationId xmlns:p14="http://schemas.microsoft.com/office/powerpoint/2010/main" val="4026177789"/>
       </p:ext>
     </p:extLst>
   </p:cSld>
@@ -15935,7 +15919,7 @@
                   <a:srgbClr val="D0D0D0"/>
                 </a:solidFill>
               </a:rPr>
-              <a:t>The Infrastructure Behind All of This</a:t>
+              <a:t>Inside the Harness</a:t>
             </a:r>
             <a:endParaRPr lang="ko-KR" altLang="en-US" sz="2400">
               <a:solidFill>
@@ -15993,7 +15977,7 @@
     </p:spTree>
     <p:extLst>
       <p:ext uri="{BB962C8B-B14F-4D97-AF65-F5344CB8AC3E}">
-        <p14:creationId xmlns:p14="http://schemas.microsoft.com/office/powerpoint/2010/main" val="3943649800"/>
+        <p14:creationId xmlns:p14="http://schemas.microsoft.com/office/powerpoint/2010/main" val="3843936867"/>
       </p:ext>
     </p:extLst>
   </p:cSld>
@@ -16358,7 +16342,7 @@
     </p:spTree>
     <p:extLst>
       <p:ext uri="{BB962C8B-B14F-4D97-AF65-F5344CB8AC3E}">
-        <p14:creationId xmlns:p14="http://schemas.microsoft.com/office/powerpoint/2010/main" val="2403273161"/>
+        <p14:creationId xmlns:p14="http://schemas.microsoft.com/office/powerpoint/2010/main" val="2706086918"/>
       </p:ext>
     </p:extLst>
   </p:cSld>
@@ -23204,7 +23188,7 @@
                 </a:solidFill>
                 <a:latin typeface="Segoe UI Semibold"/>
               </a:rPr>
-              <a:t>The Case for Function Calling</a:t>
+              <a:t>Why Harness, Not Prompt</a:t>
             </a:r>
           </a:p>
         </p:txBody>
@@ -23235,7 +23219,7 @@
                   <a:srgbClr val="D0D0D0"/>
                 </a:solidFill>
               </a:rPr>
-              <a:t>▸  A methodology for domains that demand precision</a:t>
+              <a:t>▸  Types eliminate ambiguity; schemas constrain through absence,</a:t>
             </a:r>
           </a:p>
           <a:p>
@@ -23246,7 +23230,7 @@
                   <a:srgbClr val="D0D0D0"/>
                 </a:solidFill>
               </a:rPr>
-              <a:t>▸  Constraints through structural absence, model-neutral,</a:t>
+              <a:t>    not prohibition</a:t>
             </a:r>
           </a:p>
           <a:p>
@@ -23257,7 +23241,7 @@
                   <a:srgbClr val="D0D0D0"/>
                 </a:solidFill>
               </a:rPr>
-              <a:t>    mechanically verifiable</a:t>
+              <a:t>▸  Model-neutral, mechanically verifiable, deterministically convergent</a:t>
             </a:r>
           </a:p>
         </p:txBody>
@@ -23307,8 +23291,8 @@
         </p:nvSpPr>
         <p:spPr>
           <a:xfrm>
-            <a:off x="1587500" y="3302000"/>
-            <a:ext cx="5080000" cy="508000"/>
+            <a:off x="1587499" y="3302000"/>
+            <a:ext cx="5918619" cy="508000"/>
           </a:xfrm>
           <a:prstGeom prst="rect">
             <a:avLst/>
@@ -23320,13 +23304,13 @@
           <a:p>
             <a:pPr algn="l"/>
             <a:r>
-              <a:rPr lang="en-US" sz="2400" b="1">
+              <a:rPr lang="en-US" sz="2400" b="1" dirty="0">
                 <a:solidFill>
                   <a:srgbClr val="FF6B6B"/>
                 </a:solidFill>
                 <a:latin typeface="Segoe UI Semibold"/>
               </a:rPr>
-              <a:t>Why Qwen</a:t>
+              <a:t>Qwen — Stress-Testing the Harness</a:t>
             </a:r>
           </a:p>
         </p:txBody>
@@ -23357,7 +23341,7 @@
                   <a:srgbClr val="D0D0D0"/>
                 </a:solidFill>
               </a:rPr>
-              <a:t>▸  Local models are essential for R&amp;D</a:t>
+              <a:t>▸  Small models are the best QA engineers for the harness</a:t>
             </a:r>
           </a:p>
           <a:p>
@@ -23368,18 +23352,7 @@
                   <a:srgbClr val="D0D0D0"/>
                 </a:solidFill>
               </a:rPr>
-              <a:t>▸  Small models make the best QA engineers</a:t>
-            </a:r>
-          </a:p>
-          <a:p>
-            <a:pPr algn="l"/>
-            <a:r>
-              <a:rPr lang="en-US" sz="1800">
-                <a:solidFill>
-                  <a:srgbClr val="D0D0D0"/>
-                </a:solidFill>
-              </a:rPr>
-              <a:t>▸  Open ecosystem</a:t>
+              <a:t>▸  Open weights make unlimited experimentation possible</a:t>
             </a:r>
           </a:p>
         </p:txBody>
@@ -23455,7 +23428,7 @@
                   <a:srgbClr val="FFE66D"/>
                 </a:solidFill>
               </a:rPr>
-              <a:t>correctable.</a:t>
+              <a:t>harnessed.</a:t>
             </a:r>
           </a:p>
         </p:txBody>
@@ -23463,7 +23436,7 @@
     </p:spTree>
     <p:extLst>
       <p:ext uri="{BB962C8B-B14F-4D97-AF65-F5344CB8AC3E}">
-        <p14:creationId xmlns:p14="http://schemas.microsoft.com/office/powerpoint/2010/main" val="1902296783"/>
+        <p14:creationId xmlns:p14="http://schemas.microsoft.com/office/powerpoint/2010/main" val="2470229739"/>
       </p:ext>
     </p:extLst>
   </p:cSld>
@@ -31617,7 +31590,7 @@
                   <a:srgbClr val="A0A0A0"/>
                 </a:solidFill>
               </a:rPr>
-              <a:t>— Typia: One type to rule them all</a:t>
+              <a:t>The harness is everything around it.</a:t>
             </a:r>
             <a:endParaRPr lang="ko-KR" altLang="en-US" sz="2200" i="1">
               <a:solidFill>
@@ -31630,7 +31603,7 @@
     </p:spTree>
     <p:extLst>
       <p:ext uri="{BB962C8B-B14F-4D97-AF65-F5344CB8AC3E}">
-        <p14:creationId xmlns:p14="http://schemas.microsoft.com/office/powerpoint/2010/main" val="3586181095"/>
+        <p14:creationId xmlns:p14="http://schemas.microsoft.com/office/powerpoint/2010/main" val="414347277"/>
       </p:ext>
     </p:extLst>
   </p:cSld>
@@ -31739,7 +31712,7 @@
                   <a:srgbClr val="60A5FA"/>
                 </a:solidFill>
               </a:rPr>
-              <a:t>The Case for Function Calling</a:t>
+              <a:t>Why Harness, Not Prompt</a:t>
             </a:r>
             <a:endParaRPr lang="ko-KR" altLang="en-US" sz="4800" b="1">
               <a:solidFill>
@@ -31784,7 +31757,7 @@
                   <a:srgbClr val="D0D0D0"/>
                 </a:solidFill>
               </a:rPr>
-              <a:t>The decisive means of turning probabilistic AI deterministic</a:t>
+              <a:t>Prompt engineering tinkers with the inside. The harness makes the outside rock-solid.</a:t>
             </a:r>
             <a:endParaRPr lang="ko-KR" altLang="en-US" sz="2200">
               <a:solidFill>
@@ -31846,7 +31819,7 @@
     </p:spTree>
     <p:extLst>
       <p:ext uri="{BB962C8B-B14F-4D97-AF65-F5344CB8AC3E}">
-        <p14:creationId xmlns:p14="http://schemas.microsoft.com/office/powerpoint/2010/main" val="3046401352"/>
+        <p14:creationId xmlns:p14="http://schemas.microsoft.com/office/powerpoint/2010/main" val="1037612218"/>
       </p:ext>
     </p:extLst>
   </p:cSld>
@@ -34140,7 +34113,7 @@
                   <a:srgbClr val="00D4AA"/>
                 </a:solidFill>
               </a:rPr>
-              <a:t>▸  Strong model: 1-2 retries. Weak model: 10-15. Both → 100%</a:t>
+              <a:t>▸  Strong model: 1-2 retries. Weak model: 3-4. Both → 100%</a:t>
             </a:r>
             <a:endParaRPr lang="ko-KR" altLang="en-US" sz="2000" b="1">
               <a:solidFill>
@@ -34243,7 +34216,7 @@
     </p:spTree>
     <p:extLst>
       <p:ext uri="{BB962C8B-B14F-4D97-AF65-F5344CB8AC3E}">
-        <p14:creationId xmlns:p14="http://schemas.microsoft.com/office/powerpoint/2010/main" val="1922737354"/>
+        <p14:creationId xmlns:p14="http://schemas.microsoft.com/office/powerpoint/2010/main" val="2524558494"/>
       </p:ext>
     </p:extLst>
   </p:cSld>
@@ -34797,7 +34770,7 @@
                 <a:cs typeface="Segoe UI"/>
               </a:rPr>
               <a:t>Final compilation success rate
-All 4 Qwen models  ·  same pipeline  ·  same schemas</a:t>
+All 4 Qwen models  ·  same harness  ·  same schemas</a:t>
             </a:r>
             <a:endParaRPr lang="ko-KR" altLang="en-US" sz="2200">
               <a:solidFill>
@@ -34861,7 +34834,7 @@
     </p:spTree>
     <p:extLst>
       <p:ext uri="{BB962C8B-B14F-4D97-AF65-F5344CB8AC3E}">
-        <p14:creationId xmlns:p14="http://schemas.microsoft.com/office/powerpoint/2010/main" val="3312710531"/>
+        <p14:creationId xmlns:p14="http://schemas.microsoft.com/office/powerpoint/2010/main" val="1463243212"/>
       </p:ext>
     </p:extLst>
   </p:cSld>
@@ -35502,8 +35475,8 @@
                   <a:srgbClr val="FFE66D"/>
                 </a:solidFill>
               </a:rPr>
-              <a:t>These form a deterministic chain.
-The model is probabilistic — the loop outside is deterministic.</a:t>
+              <a:t>The model is probabilistic. But the harness around the model
+is deterministic — so the process converges to 100%.</a:t>
             </a:r>
             <a:endParaRPr lang="ko-KR" altLang="en-US" sz="2000" b="1">
               <a:solidFill>
@@ -35516,7 +35489,7 @@
     </p:spTree>
     <p:extLst>
       <p:ext uri="{BB962C8B-B14F-4D97-AF65-F5344CB8AC3E}">
-        <p14:creationId xmlns:p14="http://schemas.microsoft.com/office/powerpoint/2010/main" val="241567742"/>
+        <p14:creationId xmlns:p14="http://schemas.microsoft.com/office/powerpoint/2010/main" val="405125987"/>
       </p:ext>
     </p:extLst>
   </p:cSld>
@@ -35612,10 +35585,10 @@
                   <a:srgbClr val="00D4AA"/>
                 </a:solidFill>
               </a:rPr>
-              <a:t>Typed Schema
+              <a:t>Type Schema
 + Deterministic Validator
-+ Structured Error Feedback
-= Reliable LLM Output</a:t>
++ Structured Feedback
+= Harness</a:t>
             </a:r>
             <a:endParaRPr lang="ko-KR" altLang="en-US" sz="2800" b="1">
               <a:solidFill>
@@ -35660,8 +35633,8 @@
                   <a:srgbClr val="D0D0D0"/>
                 </a:solidFill>
               </a:rPr>
-              <a:t>Prompt engineering tinkers with the inside of the model.
-Function calling makes the outside rock-solid.</a:t>
+              <a:t>Prompt engineering tries to make the probabilistic part reliable.
+The harness makes the deterministic part airtight.</a:t>
             </a:r>
             <a:endParaRPr lang="ko-KR" altLang="en-US" sz="2200">
               <a:solidFill>
@@ -35720,7 +35693,7 @@
     </p:spTree>
     <p:extLst>
       <p:ext uri="{BB962C8B-B14F-4D97-AF65-F5344CB8AC3E}">
-        <p14:creationId xmlns:p14="http://schemas.microsoft.com/office/powerpoint/2010/main" val="1171449091"/>
+        <p14:creationId xmlns:p14="http://schemas.microsoft.com/office/powerpoint/2010/main" val="4281516640"/>
       </p:ext>
     </p:extLst>
   </p:cSld>
@@ -35795,7 +35768,7 @@
               <a:t>"The LLM doesn't need
 to be accurate.
 It just needs to be
-correctable."</a:t>
+harnessed."</a:t>
             </a:r>
             <a:endParaRPr lang="ko-KR" altLang="en-US" sz="4000" b="1">
               <a:solidFill>
@@ -35907,7 +35880,7 @@
     </p:spTree>
     <p:extLst>
       <p:ext uri="{BB962C8B-B14F-4D97-AF65-F5344CB8AC3E}">
-        <p14:creationId xmlns:p14="http://schemas.microsoft.com/office/powerpoint/2010/main" val="1557652893"/>
+        <p14:creationId xmlns:p14="http://schemas.microsoft.com/office/powerpoint/2010/main" val="1854987107"/>
       </p:ext>
     </p:extLst>
   </p:cSld>
@@ -35981,7 +35954,7 @@
                 <a:latin typeface="Segoe UI Semibold"/>
                 <a:cs typeface="Segoe UI Semibold"/>
               </a:rPr>
-              <a:t>Application Spectrum: Verifiable</a:t>
+              <a:t>The Harness Is Universal</a:t>
             </a:r>
             <a:endParaRPr lang="ko-KR" altLang="en-US" sz="3200" b="1">
               <a:solidFill>
@@ -36824,7 +36797,7 @@
     </p:spTree>
     <p:extLst>
       <p:ext uri="{BB962C8B-B14F-4D97-AF65-F5344CB8AC3E}">
-        <p14:creationId xmlns:p14="http://schemas.microsoft.com/office/powerpoint/2010/main" val="1883060199"/>
+        <p14:creationId xmlns:p14="http://schemas.microsoft.com/office/powerpoint/2010/main" val="4115558832"/>
       </p:ext>
     </p:extLst>
   </p:cSld>
@@ -39013,7 +38986,7 @@
                 <a:latin typeface="Segoe UI Semibold"/>
                 <a:cs typeface="Segoe UI Semibold"/>
               </a:rPr>
-              <a:t>Where This Doesn't Apply</a:t>
+              <a:t>Where the Harness Doesn't Apply</a:t>
             </a:r>
             <a:endParaRPr lang="ko-KR" altLang="en-US" sz="3200" b="1">
               <a:solidFill>
@@ -39364,8 +39337,8 @@
                   <a:srgbClr val="00D4AA"/>
                 </a:solidFill>
               </a:rPr>
-              <a:t>But: if a domain has rules that determine correct from incorrect,
-this pattern is applicable. AutoBe proved it with code and compilers.</a:t>
+              <a:t>The harness is not a universal solution. It's a solution for domains
+where correctness is non-negotiable and mechanically verifiable.</a:t>
             </a:r>
             <a:endParaRPr lang="ko-KR" altLang="en-US" sz="2000" b="1">
               <a:solidFill>
@@ -39378,7 +39351,7 @@
     </p:spTree>
     <p:extLst>
       <p:ext uri="{BB962C8B-B14F-4D97-AF65-F5344CB8AC3E}">
-        <p14:creationId xmlns:p14="http://schemas.microsoft.com/office/powerpoint/2010/main" val="3740629047"/>
+        <p14:creationId xmlns:p14="http://schemas.microsoft.com/office/powerpoint/2010/main" val="2257839574"/>
       </p:ext>
     </p:extLst>
   </p:cSld>
@@ -39995,14 +39968,14 @@
           <a:p>
             <a:pPr algn="l"/>
             <a:r>
-              <a:rPr lang="en-US" altLang="ko-KR" sz="6000" b="1">
+              <a:rPr lang="en-US" altLang="ko-KR" sz="4800" b="1">
                 <a:solidFill>
                   <a:srgbClr val="A78BFA"/>
                 </a:solidFill>
               </a:rPr>
-              <a:t>Why Qwen</a:t>
-            </a:r>
-            <a:endParaRPr lang="ko-KR" altLang="en-US" sz="6000" b="1">
+              <a:t>Qwen</a:t>
+            </a:r>
+            <a:endParaRPr lang="ko-KR" altLang="en-US" sz="4800" b="1">
               <a:solidFill>
                 <a:srgbClr val="A78BFA"/>
               </a:solidFill>
@@ -40089,17 +40062,25 @@
           <a:p>
             <a:pPr algn="l"/>
             <a:r>
-              <a:rPr lang="en-US" altLang="ko-KR" sz="2200"/>
-              <a:t>Open models for open development</a:t>
-            </a:r>
-            <a:endParaRPr lang="ko-KR" altLang="en-US" sz="2200"/>
+              <a:rPr lang="en-US" altLang="ko-KR" sz="2200">
+                <a:solidFill>
+                  <a:srgbClr val="D0D0D0"/>
+                </a:solidFill>
+              </a:rPr>
+              <a:t>Stress-Testing the Harness</a:t>
+            </a:r>
+            <a:endParaRPr lang="ko-KR" altLang="en-US" sz="2200">
+              <a:solidFill>
+                <a:srgbClr val="D0D0D0"/>
+              </a:solidFill>
+            </a:endParaRPr>
           </a:p>
         </p:txBody>
       </p:sp>
     </p:spTree>
     <p:extLst>
       <p:ext uri="{BB962C8B-B14F-4D97-AF65-F5344CB8AC3E}">
-        <p14:creationId xmlns:p14="http://schemas.microsoft.com/office/powerpoint/2010/main" val="1566871481"/>
+        <p14:creationId xmlns:p14="http://schemas.microsoft.com/office/powerpoint/2010/main" val="780845265"/>
       </p:ext>
     </p:extLst>
   </p:cSld>
@@ -41049,13 +41030,7 @@
           <p:cNvGraphicFramePr>
             <a:graphicFrameLocks noGrp="1"/>
           </p:cNvGraphicFramePr>
-          <p:nvPr>
-            <p:extLst>
-              <p:ext uri="{D42A27DB-BD31-4B8C-83A1-F6EECF244321}">
-                <p14:modId xmlns:p14="http://schemas.microsoft.com/office/powerpoint/2010/main" val="815731855"/>
-              </p:ext>
-            </p:extLst>
-          </p:nvPr>
+          <p:nvPr/>
         </p:nvGraphicFramePr>
         <p:xfrm>
           <a:off x="762000" y="1397000"/>
@@ -41462,7 +41437,7 @@
                 </a:solidFill>
               </a:rPr>
               <a:t>10% was the most valuable result.
-Every failure pointed to a gap in our system.</a:t>
+Every failure pointed to a gap in the harness.</a:t>
             </a:r>
             <a:endParaRPr lang="ko-KR" altLang="en-US" sz="2200" b="1">
               <a:solidFill>
@@ -41509,8 +41484,8 @@
               </a:rPr>
               <a:t>Large models make mistakes less often, not never.
 "Rarely" in production = outage.
-When a 35B model can't misinterpret your schema,
-the probability of any model getting it wrong → effectively zero.</a:t>
+When the harness is tight enough that even a 35B model
+can't find a gap, the probability of any model failing → effectively zero.</a:t>
             </a:r>
             <a:endParaRPr lang="ko-KR" altLang="en-US" sz="2000">
               <a:solidFill>
@@ -41523,7 +41498,7 @@
     </p:spTree>
     <p:extLst>
       <p:ext uri="{BB962C8B-B14F-4D97-AF65-F5344CB8AC3E}">
-        <p14:creationId xmlns:p14="http://schemas.microsoft.com/office/powerpoint/2010/main" val="251799125"/>
+        <p14:creationId xmlns:p14="http://schemas.microsoft.com/office/powerpoint/2010/main" val="2731672023"/>
       </p:ext>
     </p:extLst>
   </p:cSld>
@@ -41899,7 +41874,7 @@
               </a:rPr>
               <a:t>AutoBe's schemas are model-neutral.
 JSON Schema + type validation = industry standards.
-Code stays the same when the model changes.</a:t>
+The harness stays the same when the model changes.</a:t>
             </a:r>
             <a:endParaRPr lang="ko-KR" altLang="en-US" sz="1900">
               <a:solidFill>
@@ -41912,7 +41887,7 @@
     </p:spTree>
     <p:extLst>
       <p:ext uri="{BB962C8B-B14F-4D97-AF65-F5344CB8AC3E}">
-        <p14:creationId xmlns:p14="http://schemas.microsoft.com/office/powerpoint/2010/main" val="2611803165"/>
+        <p14:creationId xmlns:p14="http://schemas.microsoft.com/office/powerpoint/2010/main" val="4218719748"/>
       </p:ext>
     </p:extLst>
   </p:cSld>
@@ -42106,7 +42081,7 @@
                   <a:srgbClr val="D0D0D0"/>
                 </a:solidFill>
               </a:rPr>
-              <a:t>1. AutoBe hardens its system using Qwen</a:t>
+              <a:t>1. AutoBe hardens its harness using Qwen</a:t>
             </a:r>
             <a:endParaRPr lang="ko-KR" altLang="en-US" sz="2000">
               <a:solidFill>
@@ -42228,7 +42203,7 @@
                   <a:srgbClr val="D0D0D0"/>
                 </a:solidFill>
               </a:rPr>
-              <a:t>2. Hardened system proves Qwen's production viability</a:t>
+              <a:t>2. The hardened harness proves Qwen's production-level viability</a:t>
             </a:r>
             <a:endParaRPr lang="ko-KR" altLang="en-US" sz="2000">
               <a:solidFill>
@@ -42538,7 +42513,7 @@
     </p:spTree>
     <p:extLst>
       <p:ext uri="{BB962C8B-B14F-4D97-AF65-F5344CB8AC3E}">
-        <p14:creationId xmlns:p14="http://schemas.microsoft.com/office/powerpoint/2010/main" val="1043978073"/>
+        <p14:creationId xmlns:p14="http://schemas.microsoft.com/office/powerpoint/2010/main" val="1193086716"/>
       </p:ext>
     </p:extLst>
   </p:cSld>
@@ -42798,7 +42773,7 @@
                   <a:srgbClr val="00D4AA"/>
                 </a:solidFill>
               </a:rPr>
-              <a:t>→  System hardening — every fix strengthens all models</a:t>
+              <a:t>→  Harness hardening — every fix strengthens all models</a:t>
             </a:r>
             <a:endParaRPr lang="ko-KR" altLang="en-US" sz="2000" b="1">
               <a:solidFill>
@@ -42901,7 +42876,7 @@
     </p:spTree>
     <p:extLst>
       <p:ext uri="{BB962C8B-B14F-4D97-AF65-F5344CB8AC3E}">
-        <p14:creationId xmlns:p14="http://schemas.microsoft.com/office/powerpoint/2010/main" val="3933311996"/>
+        <p14:creationId xmlns:p14="http://schemas.microsoft.com/office/powerpoint/2010/main" val="4185305613"/>
       </p:ext>
     </p:extLst>
   </p:cSld>
@@ -43533,7 +43508,7 @@
                   <a:srgbClr val="D0D0D0"/>
                 </a:solidFill>
               </a:rPr>
-              <a:t>Deterministic validation overcomes probabilistic LLM</a:t>
+              <a:t>Deterministic harness overcomes probabilistic LLM</a:t>
             </a:r>
             <a:endParaRPr lang="ko-KR" altLang="en-US" sz="2200">
               <a:solidFill>
@@ -43645,9 +43620,9 @@
                   <a:srgbClr val="D0D0D0"/>
                 </a:solidFill>
               </a:rPr>
-              <a:t>All 4 Qwen models, same pipeline — and this pattern
-isn't limited to coding. It transfers to any engineering field
-where deterministic validators exist.</a:t>
+              <a:t>All 4 Qwen models, same harness — and this pattern
+isn't limited to coding. Any engineering domain with
+deterministic validators can build the same harness.</a:t>
             </a:r>
             <a:endParaRPr lang="ko-KR" altLang="en-US" sz="2200">
               <a:solidFill>
@@ -43660,7 +43635,7 @@
     </p:spTree>
     <p:extLst>
       <p:ext uri="{BB962C8B-B14F-4D97-AF65-F5344CB8AC3E}">
-        <p14:creationId xmlns:p14="http://schemas.microsoft.com/office/powerpoint/2010/main" val="181343102"/>
+        <p14:creationId xmlns:p14="http://schemas.microsoft.com/office/powerpoint/2010/main" val="3316592703"/>
       </p:ext>
     </p:extLst>
   </p:cSld>
@@ -45774,7 +45749,7 @@
               <a:t>"The LLM doesn't need
 to be accurate.
 It just needs to be
-correctable."</a:t>
+harnessed."</a:t>
             </a:r>
             <a:endParaRPr lang="ko-KR" altLang="en-US" sz="4400" b="1">
               <a:solidFill>
@@ -45882,7 +45857,7 @@
     </p:spTree>
     <p:extLst>
       <p:ext uri="{BB962C8B-B14F-4D97-AF65-F5344CB8AC3E}">
-        <p14:creationId xmlns:p14="http://schemas.microsoft.com/office/powerpoint/2010/main" val="2299660879"/>
+        <p14:creationId xmlns:p14="http://schemas.microsoft.com/office/powerpoint/2010/main" val="235727544"/>
       </p:ext>
     </p:extLst>
   </p:cSld>
@@ -46184,7 +46159,7 @@
                 </a:solidFill>
               </a:rPr>
               <a:t>Developed by Wrtn Technologies  ·  wrtn.io
-Function Calling All-In  ·  Qwen Meetup Korea</a:t>
+Function Calling Harness  ·  Qwen Meetup Korea</a:t>
             </a:r>
             <a:endParaRPr lang="ko-KR" altLang="en-US">
               <a:solidFill>
@@ -46197,7 +46172,7 @@
     </p:spTree>
     <p:extLst>
       <p:ext uri="{BB962C8B-B14F-4D97-AF65-F5344CB8AC3E}">
-        <p14:creationId xmlns:p14="http://schemas.microsoft.com/office/powerpoint/2010/main" val="51598755"/>
+        <p14:creationId xmlns:p14="http://schemas.microsoft.com/office/powerpoint/2010/main" val="3667734892"/>
       </p:ext>
     </p:extLst>
   </p:cSld>
@@ -46792,7 +46767,7 @@
                 <a:latin typeface="Segoe UI Semibold"/>
                 <a:cs typeface="Segoe UI Semibold"/>
               </a:rPr>
-              <a:t>All-In Function Calling Strategy</a:t>
+              <a:t>The Function Calling Harness</a:t>
             </a:r>
             <a:endParaRPr lang="ko-KR" altLang="en-US" sz="3600" b="1">
               <a:solidFill>
@@ -48460,7 +48435,7 @@
     </p:spTree>
     <p:extLst>
       <p:ext uri="{BB962C8B-B14F-4D97-AF65-F5344CB8AC3E}">
-        <p14:creationId xmlns:p14="http://schemas.microsoft.com/office/powerpoint/2010/main" val="1136255363"/>
+        <p14:creationId xmlns:p14="http://schemas.microsoft.com/office/powerpoint/2010/main" val="2263292356"/>
       </p:ext>
     </p:extLst>
   </p:cSld>
@@ -49024,7 +48999,7 @@
 
 <file path=ppt/webextensions/taskpanes.xml><?xml version="1.0" encoding="utf-8"?>
 <wetp:taskpanes xmlns:wetp="http://schemas.microsoft.com/office/webextensions/taskpanes/2010/11">
-  <wetp:taskpane dockstate="right" visibility="0" width="350" row="0">
+  <wetp:taskpane dockstate="right" visibility="0" width="438" row="1">
     <wetp:webextensionref xmlns:r="http://schemas.openxmlformats.org/officeDocument/2006/relationships" r:id="rId1"/>
   </wetp:taskpane>
 </wetp:taskpanes>

</xml_diff>